<commit_message>
update ppt with right repo link
</commit_message>
<xml_diff>
--- a/sales dash board.pptx
+++ b/sales dash board.pptx
@@ -234,7 +234,7 @@
           <a:p>
             <a:fld id="{11699836-02B7-459A-AF64-A000817D576C}" type="datetimeFigureOut">
               <a:rPr lang="en-IN" smtClean="0"/>
-              <a:t>15-03-2026</a:t>
+              <a:t>19-03-2026</a:t>
             </a:fld>
             <a:endParaRPr lang="en-IN"/>
           </a:p>
@@ -918,7 +918,7 @@
           <a:p>
             <a:fld id="{CB3FA99E-0146-4BD9-9E30-4EB71F3A4207}" type="datetimeFigureOut">
               <a:rPr lang="en-IN" smtClean="0"/>
-              <a:t>15-03-2026</a:t>
+              <a:t>19-03-2026</a:t>
             </a:fld>
             <a:endParaRPr lang="en-IN"/>
           </a:p>
@@ -1025,7 +1025,7 @@
           <a:p>
             <a:fld id="{4EDE50D6-574B-40AF-946F-D52A04ADE379}" type="datetime1">
               <a:rPr lang="en-US" smtClean="0"/>
-              <a:t>3/15/2026</a:t>
+              <a:t>3/19/2026</a:t>
             </a:fld>
             <a:endParaRPr lang="en-US"/>
           </a:p>
@@ -1223,7 +1223,7 @@
           <a:p>
             <a:fld id="{846CE7D5-CF57-46EF-B807-FDD0502418D4}" type="datetimeFigureOut">
               <a:rPr lang="en-GB" smtClean="0"/>
-              <a:t>15/03/2026</a:t>
+              <a:t>19/03/2026</a:t>
             </a:fld>
             <a:endParaRPr lang="en-GB"/>
           </a:p>
@@ -3367,16 +3367,22 @@
               <a:rPr lang="en-IN" sz="2200" b="1" dirty="0">
                 <a:latin typeface="Franklin Gothic Book"/>
               </a:rPr>
-              <a:t>GitHub Link:</a:t>
-            </a:r>
-            <a:r>
-              <a:rPr lang="en-IN" sz="2200" b="1" dirty="0">
+              <a:t>GitHub Link</a:t>
+            </a:r>
+            <a:r>
+              <a:rPr lang="en-IN" sz="2200" b="1">
+                <a:latin typeface="Franklin Gothic Book"/>
+              </a:rPr>
+              <a:t>:</a:t>
+            </a:r>
+            <a:r>
+              <a:rPr lang="en-IN" sz="2200" b="1">
                 <a:solidFill>
                   <a:srgbClr val="0070C0"/>
                 </a:solidFill>
                 <a:latin typeface="Franklin Gothic Book"/>
               </a:rPr>
-              <a:t> </a:t>
+              <a:t> https://github.com/Uday2kranth/Superstore</a:t>
             </a:r>
             <a:endParaRPr lang="en-IN" sz="2200" u="sng" dirty="0">
               <a:solidFill>

</xml_diff>